<commit_message>
docs: update slide 5 with Gemini Flash, prompt v2 and real-CIN fix story
</commit_message>
<xml_diff>
--- a/presentation/soutenance-ocr-cin.pptx
+++ b/presentation/soutenance-ocr-cin.pptx
@@ -3856,7 +3856,7 @@
         <p:spPr>
           <a:xfrm>
             <a:off x="1016000" y="2159000"/>
-            <a:ext cx="6350000" cy="5461000"/>
+            <a:ext cx="6350000" cy="3683000"/>
           </a:xfrm>
           <a:prstGeom prst="rect">
             <a:avLst/>
@@ -3875,7 +3875,7 @@
         </p:nvSpPr>
         <p:spPr>
           <a:xfrm>
-            <a:off x="1397000" y="2540000"/>
+            <a:off x="1397000" y="2476500"/>
             <a:ext cx="5588000" cy="381000"/>
           </a:xfrm>
           <a:prstGeom prst="rect">
@@ -3914,202 +3914,8 @@
         </p:nvSpPr>
         <p:spPr>
           <a:xfrm>
-            <a:off x="1397000" y="3175000"/>
-            <a:ext cx="5588000" cy="3810000"/>
-          </a:xfrm>
-          <a:prstGeom prst="rect">
-            <a:avLst/>
-          </a:prstGeom>
-          <a:noFill/>
-          <a:ln/>
-        </p:spPr>
-        <p:txBody>
-          <a:bodyPr wrap="square" lIns="0" tIns="0" rIns="0" bIns="0" rtlCol="0" anchor="t"/>
-          <a:lstStyle/>
-          <a:p>
-            <a:pPr algn="l" indent="0" marL="0">
-              <a:lnSpc>
-                <a:spcPts val="2700"/>
-              </a:lnSpc>
-              <a:buNone/>
-            </a:pPr>
-            <a:r>
-              <a:rPr lang="en-US" altLang="en-US" sz="2000" b="1" dirty="0">
-                <a:solidFill>
-                  <a:srgbClr val="111827"/>
-                </a:solidFill>
-                <a:latin typeface="Calibri" pitchFamily="34" charset="0"/>
-                <a:ea typeface="Calibri" pitchFamily="34" charset="-122"/>
-                <a:cs typeface="Calibri" pitchFamily="34" charset="-120"/>
-              </a:rPr>
-              <a:t>Tesseract.js</a:t>
-            </a:r>
-            <a:r>
-              <a:rPr lang="en-US" altLang="en-US" sz="2000" dirty="0">
-                <a:solidFill>
-                  <a:srgbClr val="111827"/>
-                </a:solidFill>
-                <a:latin typeface="Calibri" pitchFamily="34" charset="0"/>
-                <a:ea typeface="Calibri" pitchFamily="34" charset="-122"/>
-                <a:cs typeface="Calibri" pitchFamily="34" charset="-120"/>
-              </a:rPr>
-              <a:t>, exécuté localement côté serveur.</a:t>
-            </a:r>
-            <a:endParaRPr lang="en-US" sz="2000" dirty="0"/>
-          </a:p>
-          <a:p>
-            <a:pPr algn="l" indent="0" marL="0">
-              <a:lnSpc>
-                <a:spcPts val="2700"/>
-              </a:lnSpc>
-              <a:buNone/>
-            </a:pPr>
-            <a:r>
-              <a:rPr lang="en-US" altLang="en-US" sz="2000" dirty="0">
-                <a:solidFill>
-                  <a:srgbClr val="111827"/>
-                </a:solidFill>
-                <a:latin typeface="Calibri" pitchFamily="34" charset="0"/>
-                <a:ea typeface="Calibri" pitchFamily="34" charset="-122"/>
-                <a:cs typeface="Calibri" pitchFamily="34" charset="-120"/>
-              </a:rPr>
-              <a:t>Pourquoi ce choix : gratuit, simple à intégrer dans un back Node.js, suffisant pour des spécimens fictifs propres.</a:t>
-            </a:r>
-            <a:endParaRPr lang="en-US" sz="2000" dirty="0"/>
-          </a:p>
-          <a:p>
-            <a:pPr algn="l" indent="0" marL="0">
-              <a:lnSpc>
-                <a:spcPts val="2700"/>
-              </a:lnSpc>
-              <a:buNone/>
-            </a:pPr>
-            <a:r>
-              <a:rPr lang="en-US" altLang="en-US" sz="2000" dirty="0">
-                <a:solidFill>
-                  <a:srgbClr val="111827"/>
-                </a:solidFill>
-                <a:latin typeface="Calibri" pitchFamily="34" charset="0"/>
-                <a:ea typeface="Calibri" pitchFamily="34" charset="-122"/>
-                <a:cs typeface="Calibri" pitchFamily="34" charset="-120"/>
-              </a:rPr>
-              <a:t>Ce que j'ai essayé avant : une extraction simulée sur fixtures texte, remplacée ensuite par une vraie OCR sur images PNG.</a:t>
-            </a:r>
-            <a:endParaRPr lang="en-US" sz="2000" dirty="0"/>
-          </a:p>
-          <a:p>
-            <a:pPr algn="l" indent="0" marL="0">
-              <a:lnSpc>
-                <a:spcPts val="2700"/>
-              </a:lnSpc>
-              <a:buNone/>
-            </a:pPr>
-            <a:r>
-              <a:rPr lang="en-US" altLang="en-US" sz="2000" dirty="0">
-                <a:solidFill>
-                  <a:srgbClr val="111827"/>
-                </a:solidFill>
-                <a:latin typeface="Calibri" pitchFamily="34" charset="0"/>
-                <a:ea typeface="Calibri" pitchFamily="34" charset="-122"/>
-                <a:cs typeface="Calibri" pitchFamily="34" charset="-120"/>
-              </a:rPr>
-              <a:t>Temps de réponse observé : environ </a:t>
-            </a:r>
-            <a:r>
-              <a:rPr lang="en-US" altLang="en-US" sz="2000" b="1" dirty="0">
-                <a:solidFill>
-                  <a:srgbClr val="E08A2E"/>
-                </a:solidFill>
-                <a:latin typeface="Calibri" pitchFamily="34" charset="0"/>
-                <a:ea typeface="Calibri" pitchFamily="34" charset="-122"/>
-                <a:cs typeface="Calibri" pitchFamily="34" charset="-120"/>
-              </a:rPr>
-              <a:t>0,6 à 0,9 s</a:t>
-            </a:r>
-            <a:r>
-              <a:rPr lang="en-US" altLang="en-US" sz="2000" dirty="0">
-                <a:solidFill>
-                  <a:srgbClr val="111827"/>
-                </a:solidFill>
-                <a:latin typeface="Calibri" pitchFamily="34" charset="0"/>
-                <a:ea typeface="Calibri" pitchFamily="34" charset="-122"/>
-                <a:cs typeface="Calibri" pitchFamily="34" charset="-120"/>
-              </a:rPr>
-              <a:t> par image sur le jeu de test.</a:t>
-            </a:r>
-            <a:endParaRPr lang="en-US" sz="2000" dirty="0"/>
-          </a:p>
-        </p:txBody>
-      </p:sp>
-      <p:sp>
-        <p:nvSpPr>
-          <p:cNvPr id="8" name="prompt-card"/>
-          <p:cNvSpPr/>
-          <p:nvPr/>
-        </p:nvSpPr>
-        <p:spPr>
-          <a:xfrm>
-            <a:off x="7874000" y="2159000"/>
-            <a:ext cx="7366000" cy="5461000"/>
-          </a:xfrm>
-          <a:prstGeom prst="rect">
-            <a:avLst/>
-          </a:prstGeom>
-          <a:solidFill>
-            <a:srgbClr val="E9EEFA"/>
-          </a:solidFill>
-          <a:ln/>
-        </p:spPr>
-      </p:sp>
-      <p:sp>
-        <p:nvSpPr>
-          <p:cNvPr id="9" name="prompt-title"/>
-          <p:cNvSpPr/>
-          <p:nvPr/>
-        </p:nvSpPr>
-        <p:spPr>
-          <a:xfrm>
-            <a:off x="8255000" y="2540000"/>
-            <a:ext cx="6604000" cy="381000"/>
-          </a:xfrm>
-          <a:prstGeom prst="rect">
-            <a:avLst/>
-          </a:prstGeom>
-          <a:noFill/>
-          <a:ln/>
-        </p:spPr>
-        <p:txBody>
-          <a:bodyPr wrap="square" lIns="0" tIns="0" rIns="0" bIns="0" rtlCol="0" anchor="t"/>
-          <a:lstStyle/>
-          <a:p>
-            <a:pPr algn="l" indent="0" marL="0">
-              <a:buNone/>
-            </a:pPr>
-            <a:r>
-              <a:rPr lang="en-US" altLang="en-US" sz="2400" dirty="0">
-                <a:solidFill>
-                  <a:srgbClr val="1E2761"/>
-                </a:solidFill>
-                <a:latin typeface="Calibri" pitchFamily="34" charset="0"/>
-                <a:ea typeface="Calibri" pitchFamily="34" charset="-122"/>
-                <a:cs typeface="Calibri" pitchFamily="34" charset="-120"/>
-              </a:rPr>
-              <a:t>Mon prompt / règle d'extraction</a:t>
-            </a:r>
-            <a:endParaRPr lang="en-US" sz="2400" dirty="0"/>
-          </a:p>
-        </p:txBody>
-      </p:sp>
-      <p:sp>
-        <p:nvSpPr>
-          <p:cNvPr id="10" name="prompt-body"/>
-          <p:cNvSpPr/>
-          <p:nvPr/>
-        </p:nvSpPr>
-        <p:spPr>
-          <a:xfrm>
-            <a:off x="8255000" y="3175000"/>
-            <a:ext cx="6604000" cy="3810000"/>
+            <a:off x="1397000" y="3048000"/>
+            <a:ext cx="5588000" cy="2540000"/>
           </a:xfrm>
           <a:prstGeom prst="rect">
             <a:avLst/>
@@ -4128,6 +3934,17 @@
               <a:buNone/>
             </a:pPr>
             <a:r>
+              <a:rPr lang="en-US" altLang="en-US" sz="1800" b="1" dirty="0">
+                <a:solidFill>
+                  <a:srgbClr val="111827"/>
+                </a:solidFill>
+                <a:latin typeface="Calibri" pitchFamily="34" charset="0"/>
+                <a:ea typeface="Calibri" pitchFamily="34" charset="-122"/>
+                <a:cs typeface="Calibri" pitchFamily="34" charset="-120"/>
+              </a:rPr>
+              <a:t>Gemini Flash</a:t>
+            </a:r>
+            <a:r>
               <a:rPr lang="en-US" altLang="en-US" sz="1800" dirty="0">
                 <a:solidFill>
                   <a:srgbClr val="111827"/>
@@ -4136,127 +3953,7 @@
                 <a:ea typeface="Calibri" pitchFamily="34" charset="-122"/>
                 <a:cs typeface="Calibri" pitchFamily="34" charset="-120"/>
               </a:rPr>
-              <a:t>Lecture du texte brut, puis recherche des libellés :</a:t>
-            </a:r>
-            <a:endParaRPr lang="en-US" sz="1800" dirty="0"/>
-          </a:p>
-          <a:p>
-            <a:pPr algn="l" marL="285750" indent="-285750">
-              <a:lnSpc>
-                <a:spcPts val="2340"/>
-              </a:lnSpc>
-              <a:spcBef>
-                <a:spcPts val="10"/>
-              </a:spcBef>
-              <a:buSzPct val="100000"/>
-              <a:buChar char="•"/>
-            </a:pPr>
-            <a:r>
-              <a:rPr lang="en-US" altLang="en-US" sz="1800" b="1" dirty="0">
-                <a:solidFill>
-                  <a:srgbClr val="111827"/>
-                </a:solidFill>
-                <a:latin typeface="Calibri" pitchFamily="34" charset="0"/>
-                <a:ea typeface="Calibri" pitchFamily="34" charset="-122"/>
-                <a:cs typeface="Calibri" pitchFamily="34" charset="-120"/>
-              </a:rPr>
-              <a:t>NOM</a:t>
-            </a:r>
-            <a:endParaRPr lang="en-US" sz="1800" dirty="0"/>
-          </a:p>
-          <a:p>
-            <a:pPr algn="l" marL="285750" indent="-285750">
-              <a:lnSpc>
-                <a:spcPts val="2340"/>
-              </a:lnSpc>
-              <a:spcBef>
-                <a:spcPts val="10"/>
-              </a:spcBef>
-              <a:buSzPct val="100000"/>
-              <a:buChar char="•"/>
-            </a:pPr>
-            <a:r>
-              <a:rPr lang="en-US" altLang="en-US" sz="1800" b="1" dirty="0">
-                <a:solidFill>
-                  <a:srgbClr val="111827"/>
-                </a:solidFill>
-                <a:latin typeface="Calibri" pitchFamily="34" charset="0"/>
-                <a:ea typeface="Calibri" pitchFamily="34" charset="-122"/>
-                <a:cs typeface="Calibri" pitchFamily="34" charset="-120"/>
-              </a:rPr>
-              <a:t>PRENOM</a:t>
-            </a:r>
-            <a:endParaRPr lang="en-US" sz="1800" dirty="0"/>
-          </a:p>
-          <a:p>
-            <a:pPr algn="l" marL="285750" indent="-285750">
-              <a:lnSpc>
-                <a:spcPts val="2340"/>
-              </a:lnSpc>
-              <a:spcBef>
-                <a:spcPts val="10"/>
-              </a:spcBef>
-              <a:buSzPct val="100000"/>
-              <a:buChar char="•"/>
-            </a:pPr>
-            <a:r>
-              <a:rPr lang="en-US" altLang="en-US" sz="1800" b="1" dirty="0">
-                <a:solidFill>
-                  <a:srgbClr val="111827"/>
-                </a:solidFill>
-                <a:latin typeface="Calibri" pitchFamily="34" charset="0"/>
-                <a:ea typeface="Calibri" pitchFamily="34" charset="-122"/>
-                <a:cs typeface="Calibri" pitchFamily="34" charset="-120"/>
-              </a:rPr>
-              <a:t>DATE DE NAISSANCE</a:t>
-            </a:r>
-            <a:endParaRPr lang="en-US" sz="1800" dirty="0"/>
-          </a:p>
-          <a:p>
-            <a:pPr algn="l" marL="285750" indent="-285750">
-              <a:lnSpc>
-                <a:spcPts val="2340"/>
-              </a:lnSpc>
-              <a:spcBef>
-                <a:spcPts val="10"/>
-              </a:spcBef>
-              <a:buSzPct val="100000"/>
-              <a:buChar char="•"/>
-            </a:pPr>
-            <a:r>
-              <a:rPr lang="en-US" altLang="en-US" sz="1800" b="1" dirty="0">
-                <a:solidFill>
-                  <a:srgbClr val="111827"/>
-                </a:solidFill>
-                <a:latin typeface="Calibri" pitchFamily="34" charset="0"/>
-                <a:ea typeface="Calibri" pitchFamily="34" charset="-122"/>
-                <a:cs typeface="Calibri" pitchFamily="34" charset="-120"/>
-              </a:rPr>
-              <a:t>CIN</a:t>
-            </a:r>
-            <a:endParaRPr lang="en-US" sz="1800" dirty="0"/>
-          </a:p>
-          <a:p>
-            <a:pPr algn="l" marL="285750" indent="-285750">
-              <a:lnSpc>
-                <a:spcPts val="2340"/>
-              </a:lnSpc>
-              <a:spcBef>
-                <a:spcPts val="10"/>
-              </a:spcBef>
-              <a:buSzPct val="100000"/>
-              <a:buChar char="•"/>
-            </a:pPr>
-            <a:r>
-              <a:rPr lang="en-US" altLang="en-US" sz="1800" b="1" dirty="0">
-                <a:solidFill>
-                  <a:srgbClr val="111827"/>
-                </a:solidFill>
-                <a:latin typeface="Calibri" pitchFamily="34" charset="0"/>
-                <a:ea typeface="Calibri" pitchFamily="34" charset="-122"/>
-                <a:cs typeface="Calibri" pitchFamily="34" charset="-120"/>
-              </a:rPr>
-              <a:t>VALIDE JUSQU'AU</a:t>
+              <a:t> (API hébergée, sans GPU local), palier gratuit Google AI Studio.</a:t>
             </a:r>
             <a:endParaRPr lang="en-US" sz="1800" dirty="0"/>
           </a:p>
@@ -4276,15 +3973,473 @@
                 <a:ea typeface="Calibri" pitchFamily="34" charset="-122"/>
                 <a:cs typeface="Calibri" pitchFamily="34" charset="-120"/>
               </a:rPr>
-              <a:t>Ensuite : normalisation des dates, validation du format du numéro de CIN et marquage explicite des champs illisibles.</a:t>
+              <a:t>Pourquoi : qualité de vision supérieure sur documents réels, aucune installation lourde, clé en variable d'environnement.</a:t>
             </a:r>
             <a:endParaRPr lang="en-US" sz="1800" dirty="0"/>
           </a:p>
-        </p:txBody>
-      </p:sp>
-      <p:sp>
-        <p:nvSpPr>
-          <p:cNvPr id="11" name="page-number"/>
+          <a:p>
+            <a:pPr algn="l" indent="0" marL="0">
+              <a:lnSpc>
+                <a:spcPts val="2340"/>
+              </a:lnSpc>
+              <a:buNone/>
+            </a:pPr>
+            <a:r>
+              <a:rPr lang="en-US" altLang="en-US" sz="1800" dirty="0">
+                <a:solidFill>
+                  <a:srgbClr val="111827"/>
+                </a:solidFill>
+                <a:latin typeface="Calibri" pitchFamily="34" charset="0"/>
+                <a:ea typeface="Calibri" pitchFamily="34" charset="-122"/>
+                <a:cs typeface="Calibri" pitchFamily="34" charset="-120"/>
+              </a:rPr>
+              <a:t>Repli hors-ligne : </a:t>
+            </a:r>
+            <a:r>
+              <a:rPr lang="en-US" altLang="en-US" sz="1800" b="1" dirty="0">
+                <a:solidFill>
+                  <a:srgbClr val="111827"/>
+                </a:solidFill>
+                <a:latin typeface="Calibri" pitchFamily="34" charset="0"/>
+                <a:ea typeface="Calibri" pitchFamily="34" charset="-122"/>
+                <a:cs typeface="Calibri" pitchFamily="34" charset="-120"/>
+              </a:rPr>
+              <a:t>Tesseract.js</a:t>
+            </a:r>
+            <a:r>
+              <a:rPr lang="en-US" altLang="en-US" sz="1800" dirty="0">
+                <a:solidFill>
+                  <a:srgbClr val="111827"/>
+                </a:solidFill>
+                <a:latin typeface="Calibri" pitchFamily="34" charset="0"/>
+                <a:ea typeface="Calibri" pitchFamily="34" charset="-122"/>
+                <a:cs typeface="Calibri" pitchFamily="34" charset="-120"/>
+              </a:rPr>
+              <a:t> en local si pas de connexion.</a:t>
+            </a:r>
+            <a:endParaRPr lang="en-US" sz="1800" dirty="0"/>
+          </a:p>
+          <a:p>
+            <a:pPr algn="l" indent="0" marL="0">
+              <a:lnSpc>
+                <a:spcPts val="2340"/>
+              </a:lnSpc>
+              <a:buNone/>
+            </a:pPr>
+            <a:r>
+              <a:rPr lang="en-US" altLang="en-US" sz="1800" dirty="0">
+                <a:solidFill>
+                  <a:srgbClr val="111827"/>
+                </a:solidFill>
+                <a:latin typeface="Calibri" pitchFamily="34" charset="0"/>
+                <a:ea typeface="Calibri" pitchFamily="34" charset="-122"/>
+                <a:cs typeface="Calibri" pitchFamily="34" charset="-120"/>
+              </a:rPr>
+              <a:t>Temps de réponse : environ </a:t>
+            </a:r>
+            <a:r>
+              <a:rPr lang="en-US" altLang="en-US" sz="1800" b="1" dirty="0">
+                <a:solidFill>
+                  <a:srgbClr val="E08A2E"/>
+                </a:solidFill>
+                <a:latin typeface="Calibri" pitchFamily="34" charset="0"/>
+                <a:ea typeface="Calibri" pitchFamily="34" charset="-122"/>
+                <a:cs typeface="Calibri" pitchFamily="34" charset="-120"/>
+              </a:rPr>
+              <a:t>2 s</a:t>
+            </a:r>
+            <a:r>
+              <a:rPr lang="en-US" altLang="en-US" sz="1800" dirty="0">
+                <a:solidFill>
+                  <a:srgbClr val="111827"/>
+                </a:solidFill>
+                <a:latin typeface="Calibri" pitchFamily="34" charset="0"/>
+                <a:ea typeface="Calibri" pitchFamily="34" charset="-122"/>
+                <a:cs typeface="Calibri" pitchFamily="34" charset="-120"/>
+              </a:rPr>
+              <a:t> par image.</a:t>
+            </a:r>
+            <a:endParaRPr lang="en-US" sz="1800" dirty="0"/>
+          </a:p>
+        </p:txBody>
+      </p:sp>
+      <p:sp>
+        <p:nvSpPr>
+          <p:cNvPr id="8" name="prompt-card"/>
+          <p:cNvSpPr/>
+          <p:nvPr/>
+        </p:nvSpPr>
+        <p:spPr>
+          <a:xfrm>
+            <a:off x="7874000" y="2159000"/>
+            <a:ext cx="7366000" cy="3683000"/>
+          </a:xfrm>
+          <a:prstGeom prst="rect">
+            <a:avLst/>
+          </a:prstGeom>
+          <a:solidFill>
+            <a:srgbClr val="E9EEFA"/>
+          </a:solidFill>
+          <a:ln/>
+        </p:spPr>
+      </p:sp>
+      <p:sp>
+        <p:nvSpPr>
+          <p:cNvPr id="9" name="prompt-title"/>
+          <p:cNvSpPr/>
+          <p:nvPr/>
+        </p:nvSpPr>
+        <p:spPr>
+          <a:xfrm>
+            <a:off x="8255000" y="2476500"/>
+            <a:ext cx="6604000" cy="381000"/>
+          </a:xfrm>
+          <a:prstGeom prst="rect">
+            <a:avLst/>
+          </a:prstGeom>
+          <a:noFill/>
+          <a:ln/>
+        </p:spPr>
+        <p:txBody>
+          <a:bodyPr wrap="square" lIns="0" tIns="0" rIns="0" bIns="0" rtlCol="0" anchor="t"/>
+          <a:lstStyle/>
+          <a:p>
+            <a:pPr algn="l" indent="0" marL="0">
+              <a:buNone/>
+            </a:pPr>
+            <a:r>
+              <a:rPr lang="en-US" altLang="en-US" sz="2400" dirty="0">
+                <a:solidFill>
+                  <a:srgbClr val="1E2761"/>
+                </a:solidFill>
+                <a:latin typeface="Calibri" pitchFamily="34" charset="0"/>
+                <a:ea typeface="Calibri" pitchFamily="34" charset="-122"/>
+                <a:cs typeface="Calibri" pitchFamily="34" charset="-120"/>
+              </a:rPr>
+              <a:t>Mon prompt (version 2.0)</a:t>
+            </a:r>
+            <a:endParaRPr lang="en-US" sz="2400" dirty="0"/>
+          </a:p>
+        </p:txBody>
+      </p:sp>
+      <p:sp>
+        <p:nvSpPr>
+          <p:cNvPr id="10" name="prompt-body"/>
+          <p:cNvSpPr/>
+          <p:nvPr/>
+        </p:nvSpPr>
+        <p:spPr>
+          <a:xfrm>
+            <a:off x="8255000" y="3048000"/>
+            <a:ext cx="6604000" cy="2540000"/>
+          </a:xfrm>
+          <a:prstGeom prst="rect">
+            <a:avLst/>
+          </a:prstGeom>
+          <a:noFill/>
+          <a:ln/>
+        </p:spPr>
+        <p:txBody>
+          <a:bodyPr wrap="square" lIns="0" tIns="0" rIns="0" bIns="0" rtlCol="0" anchor="t"/>
+          <a:lstStyle/>
+          <a:p>
+            <a:pPr algn="l" indent="0" marL="0">
+              <a:lnSpc>
+                <a:spcPts val="2176"/>
+              </a:lnSpc>
+              <a:buNone/>
+            </a:pPr>
+            <a:r>
+              <a:rPr lang="en-US" altLang="en-US" sz="1700" dirty="0">
+                <a:solidFill>
+                  <a:srgbClr val="111827"/>
+                </a:solidFill>
+                <a:latin typeface="Calibri" pitchFamily="34" charset="0"/>
+                <a:ea typeface="Calibri" pitchFamily="34" charset="-122"/>
+                <a:cs typeface="Calibri" pitchFamily="34" charset="-120"/>
+              </a:rPr>
+              <a:t>Le prompt décrit la </a:t>
+            </a:r>
+            <a:r>
+              <a:rPr lang="en-US" altLang="en-US" sz="1700" b="1" dirty="0">
+                <a:solidFill>
+                  <a:srgbClr val="111827"/>
+                </a:solidFill>
+                <a:latin typeface="Calibri" pitchFamily="34" charset="0"/>
+                <a:ea typeface="Calibri" pitchFamily="34" charset="-122"/>
+                <a:cs typeface="Calibri" pitchFamily="34" charset="-120"/>
+              </a:rPr>
+              <a:t>mise en page réelle</a:t>
+            </a:r>
+            <a:r>
+              <a:rPr lang="en-US" altLang="en-US" sz="1700" dirty="0">
+                <a:solidFill>
+                  <a:srgbClr val="111827"/>
+                </a:solidFill>
+                <a:latin typeface="Calibri" pitchFamily="34" charset="0"/>
+                <a:ea typeface="Calibri" pitchFamily="34" charset="-122"/>
+                <a:cs typeface="Calibri" pitchFamily="34" charset="-120"/>
+              </a:rPr>
+              <a:t> d'une CIN : photo à gauche, champs positionnels à droite, texte arabe et latin, dates au format JJ.MM.AAAA.</a:t>
+            </a:r>
+            <a:endParaRPr lang="en-US" sz="1700" dirty="0"/>
+          </a:p>
+          <a:p>
+            <a:pPr algn="l" indent="0" marL="0">
+              <a:lnSpc>
+                <a:spcPts val="2176"/>
+              </a:lnSpc>
+              <a:buNone/>
+            </a:pPr>
+            <a:r>
+              <a:rPr lang="en-US" altLang="en-US" sz="1700" dirty="0">
+                <a:solidFill>
+                  <a:srgbClr val="111827"/>
+                </a:solidFill>
+                <a:latin typeface="Calibri" pitchFamily="34" charset="0"/>
+                <a:ea typeface="Calibri" pitchFamily="34" charset="-122"/>
+                <a:cs typeface="Calibri" pitchFamily="34" charset="-120"/>
+              </a:rPr>
+              <a:t>Il impose une sortie </a:t>
+            </a:r>
+            <a:r>
+              <a:rPr lang="en-US" altLang="en-US" sz="1700" b="1" dirty="0">
+                <a:solidFill>
+                  <a:srgbClr val="111827"/>
+                </a:solidFill>
+                <a:latin typeface="Calibri" pitchFamily="34" charset="0"/>
+                <a:ea typeface="Calibri" pitchFamily="34" charset="-122"/>
+                <a:cs typeface="Calibri" pitchFamily="34" charset="-120"/>
+              </a:rPr>
+              <a:t>JSON stricte</a:t>
+            </a:r>
+            <a:r>
+              <a:rPr lang="en-US" altLang="en-US" sz="1700" dirty="0">
+                <a:solidFill>
+                  <a:srgbClr val="111827"/>
+                </a:solidFill>
+                <a:latin typeface="Calibri" pitchFamily="34" charset="0"/>
+                <a:ea typeface="Calibri" pitchFamily="34" charset="-122"/>
+                <a:cs typeface="Calibri" pitchFamily="34" charset="-120"/>
+              </a:rPr>
+              <a:t>, un </a:t>
+            </a:r>
+            <a:r>
+              <a:rPr lang="en-US" altLang="en-US" sz="1700" b="1" dirty="0">
+                <a:solidFill>
+                  <a:srgbClr val="111827"/>
+                </a:solidFill>
+                <a:latin typeface="Calibri" pitchFamily="34" charset="0"/>
+                <a:ea typeface="Calibri" pitchFamily="34" charset="-122"/>
+                <a:cs typeface="Calibri" pitchFamily="34" charset="-120"/>
+              </a:rPr>
+              <a:t>null explicite</a:t>
+            </a:r>
+            <a:r>
+              <a:rPr lang="en-US" altLang="en-US" sz="1700" dirty="0">
+                <a:solidFill>
+                  <a:srgbClr val="111827"/>
+                </a:solidFill>
+                <a:latin typeface="Calibri" pitchFamily="34" charset="0"/>
+                <a:ea typeface="Calibri" pitchFamily="34" charset="-122"/>
+                <a:cs typeface="Calibri" pitchFamily="34" charset="-120"/>
+              </a:rPr>
+              <a:t> pour tout champ illisible, et </a:t>
+            </a:r>
+            <a:r>
+              <a:rPr lang="en-US" altLang="en-US" sz="1700" b="1" dirty="0">
+                <a:solidFill>
+                  <a:srgbClr val="111827"/>
+                </a:solidFill>
+                <a:latin typeface="Calibri" pitchFamily="34" charset="0"/>
+                <a:ea typeface="Calibri" pitchFamily="34" charset="-122"/>
+                <a:cs typeface="Calibri" pitchFamily="34" charset="-120"/>
+              </a:rPr>
+              <a:t>isCin=false</a:t>
+            </a:r>
+            <a:r>
+              <a:rPr lang="en-US" altLang="en-US" sz="1700" dirty="0">
+                <a:solidFill>
+                  <a:srgbClr val="111827"/>
+                </a:solidFill>
+                <a:latin typeface="Calibri" pitchFamily="34" charset="0"/>
+                <a:ea typeface="Calibri" pitchFamily="34" charset="-122"/>
+                <a:cs typeface="Calibri" pitchFamily="34" charset="-120"/>
+              </a:rPr>
+              <a:t> si le document n'est pas une CIN.</a:t>
+            </a:r>
+            <a:endParaRPr lang="en-US" sz="1700" dirty="0"/>
+          </a:p>
+          <a:p>
+            <a:pPr algn="l" indent="0" marL="0">
+              <a:lnSpc>
+                <a:spcPts val="2176"/>
+              </a:lnSpc>
+              <a:buNone/>
+            </a:pPr>
+            <a:r>
+              <a:rPr lang="en-US" altLang="en-US" sz="1700" dirty="0">
+                <a:solidFill>
+                  <a:srgbClr val="111827"/>
+                </a:solidFill>
+                <a:latin typeface="Calibri" pitchFamily="34" charset="0"/>
+                <a:ea typeface="Calibri" pitchFamily="34" charset="-122"/>
+                <a:cs typeface="Calibri" pitchFamily="34" charset="-120"/>
+              </a:rPr>
+              <a:t>Le prompt est </a:t>
+            </a:r>
+            <a:r>
+              <a:rPr lang="en-US" altLang="en-US" sz="1700" b="1" dirty="0">
+                <a:solidFill>
+                  <a:srgbClr val="111827"/>
+                </a:solidFill>
+                <a:latin typeface="Calibri" pitchFamily="34" charset="0"/>
+                <a:ea typeface="Calibri" pitchFamily="34" charset="-122"/>
+                <a:cs typeface="Calibri" pitchFamily="34" charset="-120"/>
+              </a:rPr>
+              <a:t>versionné dans le code</a:t>
+            </a:r>
+            <a:r>
+              <a:rPr lang="en-US" altLang="en-US" sz="1700" dirty="0">
+                <a:solidFill>
+                  <a:srgbClr val="111827"/>
+                </a:solidFill>
+                <a:latin typeface="Calibri" pitchFamily="34" charset="0"/>
+                <a:ea typeface="Calibri" pitchFamily="34" charset="-122"/>
+                <a:cs typeface="Calibri" pitchFamily="34" charset="-120"/>
+              </a:rPr>
+              <a:t> (server/prompts/cinExtraction.ts).</a:t>
+            </a:r>
+            <a:endParaRPr lang="en-US" sz="1700" dirty="0"/>
+          </a:p>
+        </p:txBody>
+      </p:sp>
+      <p:sp>
+        <p:nvSpPr>
+          <p:cNvPr id="11" name="story-card"/>
+          <p:cNvSpPr/>
+          <p:nvPr/>
+        </p:nvSpPr>
+        <p:spPr>
+          <a:xfrm>
+            <a:off x="1016000" y="6223000"/>
+            <a:ext cx="14224000" cy="1778000"/>
+          </a:xfrm>
+          <a:prstGeom prst="rect">
+            <a:avLst/>
+          </a:prstGeom>
+          <a:solidFill>
+            <a:srgbClr val="F4F6FB"/>
+          </a:solidFill>
+          <a:ln/>
+        </p:spPr>
+      </p:sp>
+      <p:sp>
+        <p:nvSpPr>
+          <p:cNvPr id="12" name="story-title"/>
+          <p:cNvSpPr/>
+          <p:nvPr/>
+        </p:nvSpPr>
+        <p:spPr>
+          <a:xfrm>
+            <a:off x="1397000" y="6477000"/>
+            <a:ext cx="7620000" cy="355600"/>
+          </a:xfrm>
+          <a:prstGeom prst="rect">
+            <a:avLst/>
+          </a:prstGeom>
+          <a:noFill/>
+          <a:ln/>
+        </p:spPr>
+        <p:txBody>
+          <a:bodyPr wrap="square" lIns="0" tIns="0" rIns="0" bIns="0" rtlCol="0" anchor="t"/>
+          <a:lstStyle/>
+          <a:p>
+            <a:pPr algn="l" indent="0" marL="0">
+              <a:buNone/>
+            </a:pPr>
+            <a:r>
+              <a:rPr lang="en-US" altLang="en-US" sz="2000" dirty="0">
+                <a:solidFill>
+                  <a:srgbClr val="E08A2E"/>
+                </a:solidFill>
+                <a:latin typeface="Calibri" pitchFamily="34" charset="0"/>
+                <a:ea typeface="Calibri" pitchFamily="34" charset="-122"/>
+                <a:cs typeface="Calibri" pitchFamily="34" charset="-120"/>
+              </a:rPr>
+              <a:t>Ce que le test sur vraie CIN m'a appris</a:t>
+            </a:r>
+            <a:endParaRPr lang="en-US" sz="2000" dirty="0"/>
+          </a:p>
+        </p:txBody>
+      </p:sp>
+      <p:sp>
+        <p:nvSpPr>
+          <p:cNvPr id="13" name="story-body"/>
+          <p:cNvSpPr/>
+          <p:nvPr/>
+        </p:nvSpPr>
+        <p:spPr>
+          <a:xfrm>
+            <a:off x="1397000" y="6921500"/>
+            <a:ext cx="13462000" cy="952500"/>
+          </a:xfrm>
+          <a:prstGeom prst="rect">
+            <a:avLst/>
+          </a:prstGeom>
+          <a:noFill/>
+          <a:ln/>
+        </p:spPr>
+        <p:txBody>
+          <a:bodyPr wrap="square" lIns="0" tIns="0" rIns="0" bIns="0" rtlCol="0" anchor="t"/>
+          <a:lstStyle/>
+          <a:p>
+            <a:pPr algn="l" indent="0" marL="0">
+              <a:lnSpc>
+                <a:spcPts val="2210"/>
+              </a:lnSpc>
+              <a:buNone/>
+            </a:pPr>
+            <a:r>
+              <a:rPr lang="en-US" altLang="en-US" sz="1700" dirty="0">
+                <a:solidFill>
+                  <a:srgbClr val="111827"/>
+                </a:solidFill>
+                <a:latin typeface="Calibri" pitchFamily="34" charset="0"/>
+                <a:ea typeface="Calibri" pitchFamily="34" charset="-122"/>
+                <a:cs typeface="Calibri" pitchFamily="34" charset="-120"/>
+              </a:rPr>
+              <a:t>Mon prompt v1 cherchait des libellés explicites (« NOM : ») qui n'existent pas sur une vraie carte : tous les champs ressortaient « Non lu ». J'ai réécrit le prompt pour décrire la mise en page positionnelle réelle — l'extraction est passée à </a:t>
+            </a:r>
+            <a:r>
+              <a:rPr lang="en-US" altLang="en-US" sz="1700" b="1" dirty="0">
+                <a:solidFill>
+                  <a:srgbClr val="111827"/>
+                </a:solidFill>
+                <a:latin typeface="Calibri" pitchFamily="34" charset="0"/>
+                <a:ea typeface="Calibri" pitchFamily="34" charset="-122"/>
+                <a:cs typeface="Calibri" pitchFamily="34" charset="-120"/>
+              </a:rPr>
+              <a:t>99 % de confiance</a:t>
+            </a:r>
+            <a:r>
+              <a:rPr lang="en-US" altLang="en-US" sz="1700" dirty="0">
+                <a:solidFill>
+                  <a:srgbClr val="111827"/>
+                </a:solidFill>
+                <a:latin typeface="Calibri" pitchFamily="34" charset="0"/>
+                <a:ea typeface="Calibri" pitchFamily="34" charset="-122"/>
+                <a:cs typeface="Calibri" pitchFamily="34" charset="-120"/>
+              </a:rPr>
+              <a:t> sur le spécimen réel. C'est la différence entre un modèle et un prompt bien conçu.</a:t>
+            </a:r>
+            <a:endParaRPr lang="en-US" sz="1700" dirty="0"/>
+          </a:p>
+        </p:txBody>
+      </p:sp>
+      <p:sp>
+        <p:nvSpPr>
+          <p:cNvPr id="14" name="page-number"/>
           <p:cNvSpPr/>
           <p:nvPr/>
         </p:nvSpPr>

</xml_diff>